<commit_message>
docs: bank batch and iTax export listed as working, not outstanding
Both exist and run — the bank batch now carries all 46 employees' real
account details, and the iTax PAYE export generates the KRA return. Listing
them under "still to come" undersold what is actually built.

What genuinely remains on the iTax side is narrower and now stated as such:
the export is not yet cut to the exact P10 layout. Reading that sheet out of
the reference workbook identified eight of its columns by matching values
against our own register — basic pay, transport, overtime, fringe benefit,
housing-levy relief, personal relief and PAYE all reconcile — leaving three
(L, Y and AG) that carry values no field of ours reproduces. Those are not
being guessed at on a KRA statutory return, so the slide asks for them.

Also updated the outputs slide to mention the cost-centre report now showing
gross, fringe and cash cost rather than gross alone.

Co-Authored-By: Claude Opus 5 <noreply@anthropic.com>
</commit_message>
<xml_diff>
--- a/Nexora-Payroll-Presentation.pptx
+++ b/Nexora-Payroll-Presentation.pptx
@@ -3271,7 +3271,7 @@
                 <a:ea typeface="Calibri" pitchFamily="34" charset="-122"/>
                 <a:cs typeface="Calibri" pitchFamily="34" charset="-120"/>
               </a:rPr>
-              <a:t>Every net payment with name, bank and account number.</a:t>
+              <a:t>Every net payment with the name, bank and account number already on file.</a:t>
             </a:r>
             <a:endParaRPr lang="en-US" sz="1050" dirty="0"/>
           </a:p>
@@ -3396,7 +3396,7 @@
                 <a:ea typeface="Cambria" pitchFamily="34" charset="-122"/>
                 <a:cs typeface="Cambria" pitchFamily="34" charset="-120"/>
               </a:rPr>
-              <a:t>iTax export</a:t>
+              <a:t>iTax PAYE export</a:t>
             </a:r>
             <a:endParaRPr lang="en-US" sz="1450" dirty="0"/>
           </a:p>
@@ -3438,7 +3438,7 @@
                 <a:ea typeface="Calibri" pitchFamily="34" charset="-122"/>
                 <a:cs typeface="Calibri" pitchFamily="34" charset="-120"/>
               </a:rPr>
-              <a:t>The PAYE return laid out for KRA submission.</a:t>
+              <a:t>The PAYE return, ready for KRA submission.</a:t>
             </a:r>
             <a:endParaRPr lang="en-US" sz="1050" dirty="0"/>
           </a:p>
@@ -3772,7 +3772,7 @@
                 <a:ea typeface="Calibri" pitchFamily="34" charset="-122"/>
                 <a:cs typeface="Calibri" pitchFamily="34" charset="-120"/>
               </a:rPr>
-              <a:t>All 40 columns, plus gross, PAYE and net by cost centre.</a:t>
+              <a:t>All 40 columns, plus gross, fringe and cash cost by cost centre.</a:t>
             </a:r>
             <a:endParaRPr lang="en-US" sz="1050" dirty="0"/>
           </a:p>
@@ -5329,8 +5329,8 @@
         </p:nvSpPr>
         <p:spPr>
           <a:xfrm>
-            <a:off x="841248" y="2286000"/>
-            <a:ext cx="4937760" cy="384048"/>
+            <a:off x="841248" y="2249424"/>
+            <a:ext cx="4937760" cy="365760"/>
           </a:xfrm>
           <a:prstGeom prst="rect">
             <a:avLst/>
@@ -5344,13 +5344,13 @@
           <a:p>
             <a:pPr marL="342900" indent="-342900">
               <a:lnSpc>
-                <a:spcPts val="1400"/>
+                <a:spcPts val="1350"/>
               </a:lnSpc>
               <a:buSzPct val="100000"/>
               <a:buChar char="•"/>
             </a:pPr>
             <a:r>
-              <a:rPr lang="en-US" sz="1050" dirty="0">
+              <a:rPr lang="en-US" sz="1000" dirty="0">
                 <a:solidFill>
                   <a:srgbClr val="D6E7F3"/>
                 </a:solidFill>
@@ -5360,7 +5360,7 @@
               </a:rPr>
               <a:t>Payroll engine matched to your November figures</a:t>
             </a:r>
-            <a:endParaRPr lang="en-US" sz="1050" dirty="0"/>
+            <a:endParaRPr lang="en-US" sz="1000" dirty="0"/>
           </a:p>
         </p:txBody>
       </p:sp>
@@ -5372,8 +5372,8 @@
         </p:nvSpPr>
         <p:spPr>
           <a:xfrm>
-            <a:off x="841248" y="2706624"/>
-            <a:ext cx="4937760" cy="384048"/>
+            <a:off x="841248" y="2633472"/>
+            <a:ext cx="4937760" cy="365760"/>
           </a:xfrm>
           <a:prstGeom prst="rect">
             <a:avLst/>
@@ -5387,13 +5387,13 @@
           <a:p>
             <a:pPr marL="342900" indent="-342900">
               <a:lnSpc>
-                <a:spcPts val="1400"/>
+                <a:spcPts val="1350"/>
               </a:lnSpc>
               <a:buSzPct val="100000"/>
               <a:buChar char="•"/>
             </a:pPr>
             <a:r>
-              <a:rPr lang="en-US" sz="1050" dirty="0">
+              <a:rPr lang="en-US" sz="1000" dirty="0">
                 <a:solidFill>
                   <a:srgbClr val="D6E7F3"/>
                 </a:solidFill>
@@ -5403,7 +5403,7 @@
               </a:rPr>
               <a:t>Payslips, P9s, register and cost-centre reports</a:t>
             </a:r>
-            <a:endParaRPr lang="en-US" sz="1050" dirty="0"/>
+            <a:endParaRPr lang="en-US" sz="1000" dirty="0"/>
           </a:p>
         </p:txBody>
       </p:sp>
@@ -5415,8 +5415,8 @@
         </p:nvSpPr>
         <p:spPr>
           <a:xfrm>
-            <a:off x="841248" y="3127248"/>
-            <a:ext cx="4937760" cy="384048"/>
+            <a:off x="841248" y="3017520"/>
+            <a:ext cx="4937760" cy="365760"/>
           </a:xfrm>
           <a:prstGeom prst="rect">
             <a:avLst/>
@@ -5430,13 +5430,13 @@
           <a:p>
             <a:pPr marL="342900" indent="-342900">
               <a:lnSpc>
-                <a:spcPts val="1400"/>
+                <a:spcPts val="1350"/>
               </a:lnSpc>
               <a:buSzPct val="100000"/>
               <a:buChar char="•"/>
             </a:pPr>
             <a:r>
-              <a:rPr lang="en-US" sz="1050" dirty="0">
+              <a:rPr lang="en-US" sz="1000" dirty="0">
                 <a:solidFill>
                   <a:srgbClr val="D6E7F3"/>
                 </a:solidFill>
@@ -5446,7 +5446,7 @@
               </a:rPr>
               <a:t>AX journal in your own upload format, balanced</a:t>
             </a:r>
-            <a:endParaRPr lang="en-US" sz="1050" dirty="0"/>
+            <a:endParaRPr lang="en-US" sz="1000" dirty="0"/>
           </a:p>
         </p:txBody>
       </p:sp>
@@ -5458,8 +5458,8 @@
         </p:nvSpPr>
         <p:spPr>
           <a:xfrm>
-            <a:off x="841248" y="3547872"/>
-            <a:ext cx="4937760" cy="384048"/>
+            <a:off x="841248" y="3401568"/>
+            <a:ext cx="4937760" cy="365760"/>
           </a:xfrm>
           <a:prstGeom prst="rect">
             <a:avLst/>
@@ -5473,13 +5473,13 @@
           <a:p>
             <a:pPr marL="342900" indent="-342900">
               <a:lnSpc>
-                <a:spcPts val="1400"/>
+                <a:spcPts val="1350"/>
               </a:lnSpc>
               <a:buSzPct val="100000"/>
               <a:buChar char="•"/>
             </a:pPr>
             <a:r>
-              <a:rPr lang="en-US" sz="1050" dirty="0">
+              <a:rPr lang="en-US" sz="1000" dirty="0">
                 <a:solidFill>
                   <a:srgbClr val="D6E7F3"/>
                 </a:solidFill>
@@ -5487,9 +5487,9 @@
                 <a:ea typeface="Calibri" pitchFamily="34" charset="-122"/>
                 <a:cs typeface="Calibri" pitchFamily="34" charset="-120"/>
               </a:rPr>
-              <a:t>Bank details loaded for all 46 employees</a:t>
+              <a:t>Bank batch file, with all 46 employees' details loaded</a:t>
             </a:r>
-            <a:endParaRPr lang="en-US" sz="1050" dirty="0"/>
+            <a:endParaRPr lang="en-US" sz="1000" dirty="0"/>
           </a:p>
         </p:txBody>
       </p:sp>
@@ -5501,8 +5501,8 @@
         </p:nvSpPr>
         <p:spPr>
           <a:xfrm>
-            <a:off x="841248" y="3968496"/>
-            <a:ext cx="4937760" cy="384048"/>
+            <a:off x="841248" y="3785616"/>
+            <a:ext cx="4937760" cy="365760"/>
           </a:xfrm>
           <a:prstGeom prst="rect">
             <a:avLst/>
@@ -5516,13 +5516,56 @@
           <a:p>
             <a:pPr marL="342900" indent="-342900">
               <a:lnSpc>
-                <a:spcPts val="1400"/>
+                <a:spcPts val="1350"/>
               </a:lnSpc>
               <a:buSzPct val="100000"/>
               <a:buChar char="•"/>
             </a:pPr>
             <a:r>
-              <a:rPr lang="en-US" sz="1050" dirty="0">
+              <a:rPr lang="en-US" sz="1000" dirty="0">
+                <a:solidFill>
+                  <a:srgbClr val="D6E7F3"/>
+                </a:solidFill>
+                <a:latin typeface="Calibri" pitchFamily="34" charset="0"/>
+                <a:ea typeface="Calibri" pitchFamily="34" charset="-122"/>
+                <a:cs typeface="Calibri" pitchFamily="34" charset="-120"/>
+              </a:rPr>
+              <a:t>iTax PAYE export for the KRA return</a:t>
+            </a:r>
+            <a:endParaRPr lang="en-US" sz="1000" dirty="0"/>
+          </a:p>
+        </p:txBody>
+      </p:sp>
+      <p:sp>
+        <p:nvSpPr>
+          <p:cNvPr id="11" name="Text 9"/>
+          <p:cNvSpPr txBox="1"/>
+          <p:nvPr/>
+        </p:nvSpPr>
+        <p:spPr>
+          <a:xfrm>
+            <a:off x="841248" y="4169664"/>
+            <a:ext cx="4937760" cy="365760"/>
+          </a:xfrm>
+          <a:prstGeom prst="rect">
+            <a:avLst/>
+          </a:prstGeom>
+          <a:noFill/>
+          <a:ln/>
+        </p:spPr>
+        <p:txBody>
+          <a:bodyPr wrap="square" lIns="0" tIns="0" rIns="0" bIns="0" rtlCol="0" anchor="ctr"/>
+          <a:lstStyle/>
+          <a:p>
+            <a:pPr marL="342900" indent="-342900">
+              <a:lnSpc>
+                <a:spcPts val="1350"/>
+              </a:lnSpc>
+              <a:buSzPct val="100000"/>
+              <a:buChar char="•"/>
+            </a:pPr>
+            <a:r>
+              <a:rPr lang="en-US" sz="1000" dirty="0">
                 <a:solidFill>
                   <a:srgbClr val="D6E7F3"/>
                 </a:solidFill>
@@ -5532,20 +5575,20 @@
               </a:rPr>
               <a:t>Employee portal and staff document store</a:t>
             </a:r>
-            <a:endParaRPr lang="en-US" sz="1050" dirty="0"/>
+            <a:endParaRPr lang="en-US" sz="1000" dirty="0"/>
           </a:p>
         </p:txBody>
       </p:sp>
       <p:sp>
         <p:nvSpPr>
-          <p:cNvPr id="11" name="Text 9"/>
+          <p:cNvPr id="12" name="Text 10"/>
           <p:cNvSpPr txBox="1"/>
           <p:nvPr/>
         </p:nvSpPr>
         <p:spPr>
           <a:xfrm>
-            <a:off x="841248" y="4389120"/>
-            <a:ext cx="4937760" cy="384048"/>
+            <a:off x="841248" y="4553712"/>
+            <a:ext cx="4937760" cy="365760"/>
           </a:xfrm>
           <a:prstGeom prst="rect">
             <a:avLst/>
@@ -5559,13 +5602,13 @@
           <a:p>
             <a:pPr marL="342900" indent="-342900">
               <a:lnSpc>
-                <a:spcPts val="1400"/>
+                <a:spcPts val="1350"/>
               </a:lnSpc>
               <a:buSzPct val="100000"/>
               <a:buChar char="•"/>
             </a:pPr>
             <a:r>
-              <a:rPr lang="en-US" sz="1050" dirty="0">
+              <a:rPr lang="en-US" sz="1000" dirty="0">
                 <a:solidFill>
                   <a:srgbClr val="D6E7F3"/>
                 </a:solidFill>
@@ -5575,13 +5618,13 @@
               </a:rPr>
               <a:t>Roles, approval workflow and audit trail</a:t>
             </a:r>
-            <a:endParaRPr lang="en-US" sz="1050" dirty="0"/>
+            <a:endParaRPr lang="en-US" sz="1000" dirty="0"/>
           </a:p>
         </p:txBody>
       </p:sp>
       <p:sp>
         <p:nvSpPr>
-          <p:cNvPr id="12" name="Shape 10"/>
+          <p:cNvPr id="13" name="Shape 11"/>
           <p:cNvSpPr/>
           <p:nvPr/>
         </p:nvSpPr>
@@ -5608,7 +5651,7 @@
       </p:sp>
       <p:sp>
         <p:nvSpPr>
-          <p:cNvPr id="13" name="Text 11"/>
+          <p:cNvPr id="14" name="Text 12"/>
           <p:cNvSpPr txBox="1"/>
           <p:nvPr/>
         </p:nvSpPr>
@@ -5647,7 +5690,7 @@
       </p:sp>
       <p:sp>
         <p:nvSpPr>
-          <p:cNvPr id="14" name="Text 12"/>
+          <p:cNvPr id="15" name="Text 13"/>
           <p:cNvSpPr txBox="1"/>
           <p:nvPr/>
         </p:nvSpPr>
@@ -5690,56 +5733,13 @@
       </p:sp>
       <p:sp>
         <p:nvSpPr>
-          <p:cNvPr id="15" name="Text 13"/>
-          <p:cNvSpPr txBox="1"/>
-          <p:nvPr/>
-        </p:nvSpPr>
-        <p:spPr>
-          <a:xfrm>
-            <a:off x="6464808" y="2706624"/>
-            <a:ext cx="4937760" cy="384048"/>
-          </a:xfrm>
-          <a:prstGeom prst="rect">
-            <a:avLst/>
-          </a:prstGeom>
-          <a:noFill/>
-          <a:ln/>
-        </p:spPr>
-        <p:txBody>
-          <a:bodyPr wrap="square" lIns="0" tIns="0" rIns="0" bIns="0" rtlCol="0" anchor="ctr"/>
-          <a:lstStyle/>
-          <a:p>
-            <a:pPr marL="342900" indent="-342900">
-              <a:lnSpc>
-                <a:spcPts val="1400"/>
-              </a:lnSpc>
-              <a:buSzPct val="100000"/>
-              <a:buChar char="•"/>
-            </a:pPr>
-            <a:r>
-              <a:rPr lang="en-US" sz="1050" dirty="0">
-                <a:solidFill>
-                  <a:srgbClr val="D6E7F3"/>
-                </a:solidFill>
-                <a:latin typeface="Calibri" pitchFamily="34" charset="0"/>
-                <a:ea typeface="Calibri" pitchFamily="34" charset="-122"/>
-                <a:cs typeface="Calibri" pitchFamily="34" charset="-120"/>
-              </a:rPr>
-              <a:t>Real bank and iTax templates, to match exactly</a:t>
-            </a:r>
-            <a:endParaRPr lang="en-US" sz="1050" dirty="0"/>
-          </a:p>
-        </p:txBody>
-      </p:sp>
-      <p:sp>
-        <p:nvSpPr>
           <p:cNvPr id="16" name="Text 14"/>
           <p:cNvSpPr txBox="1"/>
           <p:nvPr/>
         </p:nvSpPr>
         <p:spPr>
           <a:xfrm>
-            <a:off x="6464808" y="3127248"/>
+            <a:off x="6464808" y="2706624"/>
             <a:ext cx="4937760" cy="384048"/>
           </a:xfrm>
           <a:prstGeom prst="rect">
@@ -5782,7 +5782,7 @@
         </p:nvSpPr>
         <p:spPr>
           <a:xfrm>
-            <a:off x="6464808" y="3547872"/>
+            <a:off x="6464808" y="3127248"/>
             <a:ext cx="4937760" cy="384048"/>
           </a:xfrm>
           <a:prstGeom prst="rect">
@@ -5825,6 +5825,49 @@
         </p:nvSpPr>
         <p:spPr>
           <a:xfrm>
+            <a:off x="6464808" y="3547872"/>
+            <a:ext cx="4937760" cy="384048"/>
+          </a:xfrm>
+          <a:prstGeom prst="rect">
+            <a:avLst/>
+          </a:prstGeom>
+          <a:noFill/>
+          <a:ln/>
+        </p:spPr>
+        <p:txBody>
+          <a:bodyPr wrap="square" lIns="0" tIns="0" rIns="0" bIns="0" rtlCol="0" anchor="ctr"/>
+          <a:lstStyle/>
+          <a:p>
+            <a:pPr marL="342900" indent="-342900">
+              <a:lnSpc>
+                <a:spcPts val="1400"/>
+              </a:lnSpc>
+              <a:buSzPct val="100000"/>
+              <a:buChar char="•"/>
+            </a:pPr>
+            <a:r>
+              <a:rPr lang="en-US" sz="1050" dirty="0">
+                <a:solidFill>
+                  <a:srgbClr val="D6E7F3"/>
+                </a:solidFill>
+                <a:latin typeface="Calibri" pitchFamily="34" charset="0"/>
+                <a:ea typeface="Calibri" pitchFamily="34" charset="-122"/>
+                <a:cs typeface="Calibri" pitchFamily="34" charset="-120"/>
+              </a:rPr>
+              <a:t>iTax export re-cut to your exact P10 layout — 3 columns to confirm</a:t>
+            </a:r>
+            <a:endParaRPr lang="en-US" sz="1050" dirty="0"/>
+          </a:p>
+        </p:txBody>
+      </p:sp>
+      <p:sp>
+        <p:nvSpPr>
+          <p:cNvPr id="19" name="Text 17"/>
+          <p:cNvSpPr txBox="1"/>
+          <p:nvPr/>
+        </p:nvSpPr>
+        <p:spPr>
+          <a:xfrm>
             <a:off x="6464808" y="3968496"/>
             <a:ext cx="4937760" cy="384048"/>
           </a:xfrm>
@@ -5862,7 +5905,7 @@
       </p:sp>
       <p:sp>
         <p:nvSpPr>
-          <p:cNvPr id="19" name="Text 17"/>
+          <p:cNvPr id="20" name="Text 18"/>
           <p:cNvSpPr txBox="1"/>
           <p:nvPr/>
         </p:nvSpPr>
@@ -5901,7 +5944,7 @@
       </p:sp>
       <p:sp>
         <p:nvSpPr>
-          <p:cNvPr id="20" name="Text 18"/>
+          <p:cNvPr id="21" name="Text 19"/>
           <p:cNvSpPr txBox="1"/>
           <p:nvPr/>
         </p:nvSpPr>
@@ -5940,7 +5983,7 @@
       </p:sp>
       <p:pic>
         <p:nvPicPr>
-          <p:cNvPr id="21" name="Image 0" descr="nexora-mark.png">    </p:cNvPr>
+          <p:cNvPr id="22" name="Image 0" descr="nexora-mark.png">    </p:cNvPr>
           <p:cNvPicPr>
             <a:picLocks noChangeAspect="1"/>
           </p:cNvPicPr>
@@ -5964,7 +6007,7 @@
       </p:pic>
       <p:sp>
         <p:nvSpPr>
-          <p:cNvPr id="22" name="Text 19"/>
+          <p:cNvPr id="23" name="Text 20"/>
           <p:cNvSpPr txBox="1"/>
           <p:nvPr/>
         </p:nvSpPr>
@@ -6003,7 +6046,7 @@
       </p:sp>
       <p:sp>
         <p:nvSpPr>
-          <p:cNvPr id="23" name="Text 20"/>
+          <p:cNvPr id="24" name="Text 21"/>
           <p:cNvSpPr txBox="1"/>
           <p:nvPr/>
         </p:nvSpPr>

</xml_diff>

<commit_message>
docs: deck reflects the real bank layout, the full GL summary, and a fourth question
The bank batch file is now built to Chrysal's own upload layout rather than a
placeholder, and the AX GL panel lists every line that posts, so the slides
say so instead of describing what the placeholder did.

A fourth item joins the confirm list: the source bank file gives staff 1011
and 1012 the same reference (EMP011), and 1029 and 1031 both EMP032. Two
people sharing a payment reference is the kind of thing a bank queries or
misapplies, so it is worth raising alongside the accounting questions.

Also dropped a line on the employer-pension item that no longer holds — it
still cited three cost centres disagreeing, which the formula correction
resolved. The KES 1,740 observation, which is the useful part, stays.

Co-Authored-By: Claude Opus 5 <noreply@anthropic.com>
</commit_message>
<xml_diff>
--- a/Nexora-Payroll-Presentation.pptx
+++ b/Nexora-Payroll-Presentation.pptx
@@ -3271,7 +3271,7 @@
                 <a:ea typeface="Calibri" pitchFamily="34" charset="-122"/>
                 <a:cs typeface="Calibri" pitchFamily="34" charset="-120"/>
               </a:rPr>
-              <a:t>Every net payment with the name, bank and account number already on file.</a:t>
+              <a:t>Built to your bank's own layout — header, debit, 46 payments, trailer.</a:t>
             </a:r>
             <a:endParaRPr lang="en-US" sz="1050" dirty="0"/>
           </a:p>
@@ -5487,7 +5487,7 @@
                 <a:ea typeface="Calibri" pitchFamily="34" charset="-122"/>
                 <a:cs typeface="Calibri" pitchFamily="34" charset="-120"/>
               </a:rPr>
-              <a:t>Bank batch file, with all 46 employees' details loaded</a:t>
+              <a:t>Bank batch file, matching your bank's own upload layout</a:t>
             </a:r>
             <a:endParaRPr lang="en-US" sz="1000" dirty="0"/>
           </a:p>
@@ -5811,7 +5811,7 @@
                 <a:ea typeface="Calibri" pitchFamily="34" charset="-122"/>
                 <a:cs typeface="Calibri" pitchFamily="34" charset="-120"/>
               </a:rPr>
-              <a:t>Your answers on the three open items</a:t>
+              <a:t>Your answers on the four open items</a:t>
             </a:r>
             <a:endParaRPr lang="en-US" sz="1050" dirty="0"/>
           </a:p>
@@ -19464,7 +19464,7 @@
                 <a:ea typeface="Calibri" pitchFamily="34" charset="-122"/>
                 <a:cs typeface="Calibri" pitchFamily="34" charset="-120"/>
               </a:rPr>
-              <a:t>journal lines</a:t>
+              <a:t>journal lines, all on screen</a:t>
             </a:r>
             <a:endParaRPr lang="en-US" sz="1100" dirty="0"/>
           </a:p>
@@ -19887,7 +19887,7 @@
                 <a:ea typeface="Cambria" pitchFamily="34" charset="-122"/>
                 <a:cs typeface="Cambria" pitchFamily="34" charset="-120"/>
               </a:rPr>
-              <a:t>Three things we'd like you to confirm</a:t>
+              <a:t>Four things we'd like you to confirm</a:t>
             </a:r>
             <a:endParaRPr lang="en-US" sz="3100" dirty="0"/>
           </a:p>
@@ -19926,7 +19926,7 @@
                 <a:ea typeface="Calibri" pitchFamily="34" charset="-122"/>
                 <a:cs typeface="Calibri" pitchFamily="34" charset="-120"/>
               </a:rPr>
-              <a:t>Everything else matches. These three don't — and we'd rather show them than let you find them.</a:t>
+              <a:t>Everything else matches. These four don't — and we'd rather show them than let you find them.</a:t>
             </a:r>
             <a:endParaRPr lang="en-US" sz="1250" dirty="0"/>
           </a:p>
@@ -19940,12 +19940,12 @@
         </p:nvSpPr>
         <p:spPr>
           <a:xfrm>
-            <a:off x="566928" y="1773936"/>
-            <a:ext cx="11055096" cy="1243584"/>
+            <a:off x="566928" y="1737360"/>
+            <a:ext cx="11055096" cy="1078992"/>
           </a:xfrm>
           <a:prstGeom prst="roundRect">
             <a:avLst>
-              <a:gd name="adj" fmla="val 5882"/>
+              <a:gd name="adj" fmla="val 6780"/>
             </a:avLst>
           </a:prstGeom>
           <a:solidFill>
@@ -19967,8 +19967,8 @@
         </p:nvSpPr>
         <p:spPr>
           <a:xfrm>
-            <a:off x="804672" y="1993392"/>
-            <a:ext cx="365760" cy="365760"/>
+            <a:off x="804672" y="1920240"/>
+            <a:ext cx="347472" cy="347472"/>
           </a:xfrm>
           <a:prstGeom prst="ellipse">
             <a:avLst/>
@@ -19987,8 +19987,8 @@
         </p:nvSpPr>
         <p:spPr>
           <a:xfrm>
-            <a:off x="804672" y="1993392"/>
-            <a:ext cx="365760" cy="365760"/>
+            <a:off x="804672" y="1920240"/>
+            <a:ext cx="347472" cy="347472"/>
           </a:xfrm>
           <a:prstGeom prst="rect">
             <a:avLst/>
@@ -20004,7 +20004,7 @@
               <a:buNone/>
             </a:pPr>
             <a:r>
-              <a:rPr lang="en-US" sz="1200" b="1" dirty="0">
+              <a:rPr lang="en-US" sz="1150" b="1" dirty="0">
                 <a:solidFill>
                   <a:srgbClr val="FFFFFF"/>
                 </a:solidFill>
@@ -20014,7 +20014,7 @@
               </a:rPr>
               <a:t>1</a:t>
             </a:r>
-            <a:endParaRPr lang="en-US" sz="1200" dirty="0"/>
+            <a:endParaRPr lang="en-US" sz="1150" dirty="0"/>
           </a:p>
         </p:txBody>
       </p:sp>
@@ -20026,8 +20026,8 @@
         </p:nvSpPr>
         <p:spPr>
           <a:xfrm>
-            <a:off x="1298448" y="1920240"/>
-            <a:ext cx="2651760" cy="274320"/>
+            <a:off x="1280160" y="1856232"/>
+            <a:ext cx="2651760" cy="256032"/>
           </a:xfrm>
           <a:prstGeom prst="rect">
             <a:avLst/>
@@ -20043,7 +20043,7 @@
               <a:buNone/>
             </a:pPr>
             <a:r>
-              <a:rPr lang="en-US" sz="1350" b="1" dirty="0">
+              <a:rPr lang="en-US" sz="1250" b="1" dirty="0">
                 <a:solidFill>
                   <a:srgbClr val="16232E"/>
                 </a:solidFill>
@@ -20053,7 +20053,7 @@
               </a:rPr>
               <a:t>Employer pension</a:t>
             </a:r>
-            <a:endParaRPr lang="en-US" sz="1350" dirty="0"/>
+            <a:endParaRPr lang="en-US" sz="1250" dirty="0"/>
           </a:p>
         </p:txBody>
       </p:sp>
@@ -20065,8 +20065,50 @@
         </p:nvSpPr>
         <p:spPr>
           <a:xfrm>
-            <a:off x="1298448" y="2212848"/>
-            <a:ext cx="2651760" cy="713232"/>
+            <a:off x="1280160" y="2121408"/>
+            <a:ext cx="2651760" cy="640080"/>
+          </a:xfrm>
+          <a:prstGeom prst="rect">
+            <a:avLst/>
+          </a:prstGeom>
+          <a:noFill/>
+          <a:ln/>
+        </p:spPr>
+        <p:txBody>
+          <a:bodyPr wrap="square" lIns="0" tIns="0" rIns="0" bIns="0" rtlCol="0" anchor="ctr"/>
+          <a:lstStyle/>
+          <a:p>
+            <a:pPr indent="0" marL="0">
+              <a:lnSpc>
+                <a:spcPts val="1200"/>
+              </a:lnSpc>
+              <a:buNone/>
+            </a:pPr>
+            <a:r>
+              <a:rPr lang="en-US" sz="950" dirty="0">
+                <a:solidFill>
+                  <a:srgbClr val="5D6E7C"/>
+                </a:solidFill>
+                <a:latin typeface="Calibri" pitchFamily="34" charset="0"/>
+                <a:ea typeface="Calibri" pitchFamily="34" charset="-122"/>
+                <a:cs typeface="Calibri" pitchFamily="34" charset="-120"/>
+              </a:rPr>
+              <a:t>Your workbook totals KES 585,199.19; the system calculates KES 606,144.06 — exactly 10% of basic pay.</a:t>
+            </a:r>
+            <a:endParaRPr lang="en-US" sz="950" dirty="0"/>
+          </a:p>
+        </p:txBody>
+      </p:sp>
+      <p:sp>
+        <p:nvSpPr>
+          <p:cNvPr id="10" name="Text 8"/>
+          <p:cNvSpPr txBox="1"/>
+          <p:nvPr/>
+        </p:nvSpPr>
+        <p:spPr>
+          <a:xfrm>
+            <a:off x="4114800" y="1883664"/>
+            <a:ext cx="4572000" cy="859536"/>
           </a:xfrm>
           <a:prstGeom prst="rect">
             <a:avLst/>
@@ -20093,7 +20135,7 @@
                 <a:ea typeface="Calibri" pitchFamily="34" charset="-122"/>
                 <a:cs typeface="Calibri" pitchFamily="34" charset="-120"/>
               </a:rPr>
-              <a:t>Your workbook totals KES 585,199.19; the system calculates KES 606,144.06 — exactly 10% of basic pay.</a:t>
+              <a:t>For staff 1000 your figure is higher than ours by exactly KES 1,740 — which happens to be the NSSF Tier II amount.</a:t>
             </a:r>
             <a:endParaRPr lang="en-US" sz="1000" dirty="0"/>
           </a:p>
@@ -20101,14 +20143,14 @@
       </p:sp>
       <p:sp>
         <p:nvSpPr>
-          <p:cNvPr id="10" name="Text 8"/>
+          <p:cNvPr id="11" name="Text 9"/>
           <p:cNvSpPr txBox="1"/>
           <p:nvPr/>
         </p:nvSpPr>
         <p:spPr>
           <a:xfrm>
-            <a:off x="4133088" y="1938528"/>
-            <a:ext cx="4572000" cy="969264"/>
+            <a:off x="8887968" y="1883664"/>
+            <a:ext cx="2468880" cy="859536"/>
           </a:xfrm>
           <a:prstGeom prst="rect">
             <a:avLst/>
@@ -20122,54 +20164,12 @@
           <a:p>
             <a:pPr indent="0" marL="0">
               <a:lnSpc>
-                <a:spcPts val="1400"/>
+                <a:spcPts val="1250"/>
               </a:lnSpc>
               <a:buNone/>
             </a:pPr>
             <a:r>
-              <a:rPr lang="en-US" sz="1050" dirty="0">
-                <a:solidFill>
-                  <a:srgbClr val="5D6E7C"/>
-                </a:solidFill>
-                <a:latin typeface="Calibri" pitchFamily="34" charset="0"/>
-                <a:ea typeface="Calibri" pitchFamily="34" charset="-122"/>
-                <a:cs typeface="Calibri" pitchFamily="34" charset="-120"/>
-              </a:rPr>
-              <a:t>Three cost centres agree to the cent, three don't. For staff 1000 your figure is higher by exactly KES 1,740 — the NSSF Tier II amount.</a:t>
-            </a:r>
-            <a:endParaRPr lang="en-US" sz="1050" dirty="0"/>
-          </a:p>
-        </p:txBody>
-      </p:sp>
-      <p:sp>
-        <p:nvSpPr>
-          <p:cNvPr id="11" name="Text 9"/>
-          <p:cNvSpPr txBox="1"/>
-          <p:nvPr/>
-        </p:nvSpPr>
-        <p:spPr>
-          <a:xfrm>
-            <a:off x="8887968" y="1938528"/>
-            <a:ext cx="2468880" cy="969264"/>
-          </a:xfrm>
-          <a:prstGeom prst="rect">
-            <a:avLst/>
-          </a:prstGeom>
-          <a:noFill/>
-          <a:ln/>
-        </p:spPr>
-        <p:txBody>
-          <a:bodyPr wrap="square" lIns="0" tIns="0" rIns="0" bIns="0" rtlCol="0" anchor="ctr"/>
-          <a:lstStyle/>
-          <a:p>
-            <a:pPr indent="0" marL="0">
-              <a:lnSpc>
-                <a:spcPts val="1350"/>
-              </a:lnSpc>
-              <a:buNone/>
-            </a:pPr>
-            <a:r>
-              <a:rPr lang="en-US" sz="1000" b="1" dirty="0">
+              <a:rPr lang="en-US" sz="950" b="1" dirty="0">
                 <a:solidFill>
                   <a:srgbClr val="16232E"/>
                 </a:solidFill>
@@ -20181,12 +20181,12 @@
             </a:r>
             <a:pPr indent="0" marL="0">
               <a:lnSpc>
-                <a:spcPts val="1350"/>
+                <a:spcPts val="1250"/>
               </a:lnSpc>
               <a:buNone/>
             </a:pPr>
             <a:r>
-              <a:rPr lang="en-US" sz="1000" dirty="0">
+              <a:rPr lang="en-US" sz="950" dirty="0">
                 <a:solidFill>
                   <a:srgbClr val="5D6E7C"/>
                 </a:solidFill>
@@ -20196,7 +20196,7 @@
               </a:rPr>
               <a:t>Does it include employer NSSF, and is anyone outside the scheme?</a:t>
             </a:r>
-            <a:endParaRPr lang="en-US" sz="1000" dirty="0"/>
+            <a:endParaRPr lang="en-US" sz="950" dirty="0"/>
           </a:p>
         </p:txBody>
       </p:sp>
@@ -20208,12 +20208,12 @@
         </p:nvSpPr>
         <p:spPr>
           <a:xfrm>
-            <a:off x="566928" y="3145536"/>
-            <a:ext cx="11055096" cy="1243584"/>
+            <a:off x="566928" y="2926080"/>
+            <a:ext cx="11055096" cy="1078992"/>
           </a:xfrm>
           <a:prstGeom prst="roundRect">
             <a:avLst>
-              <a:gd name="adj" fmla="val 5882"/>
+              <a:gd name="adj" fmla="val 6780"/>
             </a:avLst>
           </a:prstGeom>
           <a:solidFill>
@@ -20235,8 +20235,8 @@
         </p:nvSpPr>
         <p:spPr>
           <a:xfrm>
-            <a:off x="804672" y="3364992"/>
-            <a:ext cx="365760" cy="365760"/>
+            <a:off x="804672" y="3108960"/>
+            <a:ext cx="347472" cy="347472"/>
           </a:xfrm>
           <a:prstGeom prst="ellipse">
             <a:avLst/>
@@ -20255,8 +20255,8 @@
         </p:nvSpPr>
         <p:spPr>
           <a:xfrm>
-            <a:off x="804672" y="3364992"/>
-            <a:ext cx="365760" cy="365760"/>
+            <a:off x="804672" y="3108960"/>
+            <a:ext cx="347472" cy="347472"/>
           </a:xfrm>
           <a:prstGeom prst="rect">
             <a:avLst/>
@@ -20272,7 +20272,7 @@
               <a:buNone/>
             </a:pPr>
             <a:r>
-              <a:rPr lang="en-US" sz="1200" b="1" dirty="0">
+              <a:rPr lang="en-US" sz="1150" b="1" dirty="0">
                 <a:solidFill>
                   <a:srgbClr val="FFFFFF"/>
                 </a:solidFill>
@@ -20282,7 +20282,7 @@
               </a:rPr>
               <a:t>2</a:t>
             </a:r>
-            <a:endParaRPr lang="en-US" sz="1200" dirty="0"/>
+            <a:endParaRPr lang="en-US" sz="1150" dirty="0"/>
           </a:p>
         </p:txBody>
       </p:sp>
@@ -20294,8 +20294,8 @@
         </p:nvSpPr>
         <p:spPr>
           <a:xfrm>
-            <a:off x="1298448" y="3291840"/>
-            <a:ext cx="2651760" cy="274320"/>
+            <a:off x="1280160" y="3044952"/>
+            <a:ext cx="2651760" cy="256032"/>
           </a:xfrm>
           <a:prstGeom prst="rect">
             <a:avLst/>
@@ -20311,7 +20311,7 @@
               <a:buNone/>
             </a:pPr>
             <a:r>
-              <a:rPr lang="en-US" sz="1350" b="1" dirty="0">
+              <a:rPr lang="en-US" sz="1250" b="1" dirty="0">
                 <a:solidFill>
                   <a:srgbClr val="16232E"/>
                 </a:solidFill>
@@ -20321,7 +20321,7 @@
               </a:rPr>
               <a:t>NITA levy</a:t>
             </a:r>
-            <a:endParaRPr lang="en-US" sz="1350" dirty="0"/>
+            <a:endParaRPr lang="en-US" sz="1250" dirty="0"/>
           </a:p>
         </p:txBody>
       </p:sp>
@@ -20333,8 +20333,50 @@
         </p:nvSpPr>
         <p:spPr>
           <a:xfrm>
-            <a:off x="1298448" y="3584448"/>
-            <a:ext cx="2651760" cy="713232"/>
+            <a:off x="1280160" y="3310128"/>
+            <a:ext cx="2651760" cy="640080"/>
+          </a:xfrm>
+          <a:prstGeom prst="rect">
+            <a:avLst/>
+          </a:prstGeom>
+          <a:noFill/>
+          <a:ln/>
+        </p:spPr>
+        <p:txBody>
+          <a:bodyPr wrap="square" lIns="0" tIns="0" rIns="0" bIns="0" rtlCol="0" anchor="ctr"/>
+          <a:lstStyle/>
+          <a:p>
+            <a:pPr indent="0" marL="0">
+              <a:lnSpc>
+                <a:spcPts val="1200"/>
+              </a:lnSpc>
+              <a:buNone/>
+            </a:pPr>
+            <a:r>
+              <a:rPr lang="en-US" sz="950" dirty="0">
+                <a:solidFill>
+                  <a:srgbClr val="5D6E7C"/>
+                </a:solidFill>
+                <a:latin typeface="Calibri" pitchFamily="34" charset="0"/>
+                <a:ea typeface="Calibri" pitchFamily="34" charset="-122"/>
+                <a:cs typeface="Calibri" pitchFamily="34" charset="-120"/>
+              </a:rPr>
+              <a:t>Your summary row shows KES 2,400. Your own GL working shows KES 2,300 — and so do we.</a:t>
+            </a:r>
+            <a:endParaRPr lang="en-US" sz="950" dirty="0"/>
+          </a:p>
+        </p:txBody>
+      </p:sp>
+      <p:sp>
+        <p:nvSpPr>
+          <p:cNvPr id="17" name="Text 15"/>
+          <p:cNvSpPr txBox="1"/>
+          <p:nvPr/>
+        </p:nvSpPr>
+        <p:spPr>
+          <a:xfrm>
+            <a:off x="4114800" y="3072384"/>
+            <a:ext cx="4572000" cy="859536"/>
           </a:xfrm>
           <a:prstGeom prst="rect">
             <a:avLst/>
@@ -20361,7 +20403,7 @@
                 <a:ea typeface="Calibri" pitchFamily="34" charset="-122"/>
                 <a:cs typeface="Calibri" pitchFamily="34" charset="-120"/>
               </a:rPr>
-              <a:t>Your summary row shows KES 2,400. Your own GL working shows KES 2,300 — and so do we.</a:t>
+              <a:t>KES 2,300 is 46 employees at KES 50, which matches the headcount.</a:t>
             </a:r>
             <a:endParaRPr lang="en-US" sz="1000" dirty="0"/>
           </a:p>
@@ -20369,14 +20411,14 @@
       </p:sp>
       <p:sp>
         <p:nvSpPr>
-          <p:cNvPr id="17" name="Text 15"/>
+          <p:cNvPr id="18" name="Text 16"/>
           <p:cNvSpPr txBox="1"/>
           <p:nvPr/>
         </p:nvSpPr>
         <p:spPr>
           <a:xfrm>
-            <a:off x="4133088" y="3310128"/>
-            <a:ext cx="4572000" cy="969264"/>
+            <a:off x="8887968" y="3072384"/>
+            <a:ext cx="2468880" cy="859536"/>
           </a:xfrm>
           <a:prstGeom prst="rect">
             <a:avLst/>
@@ -20390,54 +20432,12 @@
           <a:p>
             <a:pPr indent="0" marL="0">
               <a:lnSpc>
-                <a:spcPts val="1400"/>
+                <a:spcPts val="1250"/>
               </a:lnSpc>
               <a:buNone/>
             </a:pPr>
             <a:r>
-              <a:rPr lang="en-US" sz="1050" dirty="0">
-                <a:solidFill>
-                  <a:srgbClr val="5D6E7C"/>
-                </a:solidFill>
-                <a:latin typeface="Calibri" pitchFamily="34" charset="0"/>
-                <a:ea typeface="Calibri" pitchFamily="34" charset="-122"/>
-                <a:cs typeface="Calibri" pitchFamily="34" charset="-120"/>
-              </a:rPr>
-              <a:t>KES 2,300 is 46 employees at KES 50, which matches the headcount.</a:t>
-            </a:r>
-            <a:endParaRPr lang="en-US" sz="1050" dirty="0"/>
-          </a:p>
-        </p:txBody>
-      </p:sp>
-      <p:sp>
-        <p:nvSpPr>
-          <p:cNvPr id="18" name="Text 16"/>
-          <p:cNvSpPr txBox="1"/>
-          <p:nvPr/>
-        </p:nvSpPr>
-        <p:spPr>
-          <a:xfrm>
-            <a:off x="8887968" y="3310128"/>
-            <a:ext cx="2468880" cy="969264"/>
-          </a:xfrm>
-          <a:prstGeom prst="rect">
-            <a:avLst/>
-          </a:prstGeom>
-          <a:noFill/>
-          <a:ln/>
-        </p:spPr>
-        <p:txBody>
-          <a:bodyPr wrap="square" lIns="0" tIns="0" rIns="0" bIns="0" rtlCol="0" anchor="ctr"/>
-          <a:lstStyle/>
-          <a:p>
-            <a:pPr indent="0" marL="0">
-              <a:lnSpc>
-                <a:spcPts val="1350"/>
-              </a:lnSpc>
-              <a:buNone/>
-            </a:pPr>
-            <a:r>
-              <a:rPr lang="en-US" sz="1000" b="1" dirty="0">
+              <a:rPr lang="en-US" sz="950" b="1" dirty="0">
                 <a:solidFill>
                   <a:srgbClr val="16232E"/>
                 </a:solidFill>
@@ -20449,12 +20449,12 @@
             </a:r>
             <a:pPr indent="0" marL="0">
               <a:lnSpc>
-                <a:spcPts val="1350"/>
+                <a:spcPts val="1250"/>
               </a:lnSpc>
               <a:buNone/>
             </a:pPr>
             <a:r>
-              <a:rPr lang="en-US" sz="1000" dirty="0">
+              <a:rPr lang="en-US" sz="950" dirty="0">
                 <a:solidFill>
                   <a:srgbClr val="5D6E7C"/>
                 </a:solidFill>
@@ -20464,7 +20464,7 @@
               </a:rPr>
               <a:t>Can we treat KES 2,300 as correct?</a:t>
             </a:r>
-            <a:endParaRPr lang="en-US" sz="1000" dirty="0"/>
+            <a:endParaRPr lang="en-US" sz="950" dirty="0"/>
           </a:p>
         </p:txBody>
       </p:sp>
@@ -20476,12 +20476,12 @@
         </p:nvSpPr>
         <p:spPr>
           <a:xfrm>
-            <a:off x="566928" y="4517136"/>
-            <a:ext cx="11055096" cy="1243584"/>
+            <a:off x="566928" y="4114800"/>
+            <a:ext cx="11055096" cy="1078992"/>
           </a:xfrm>
           <a:prstGeom prst="roundRect">
             <a:avLst>
-              <a:gd name="adj" fmla="val 5882"/>
+              <a:gd name="adj" fmla="val 6780"/>
             </a:avLst>
           </a:prstGeom>
           <a:solidFill>
@@ -20503,8 +20503,8 @@
         </p:nvSpPr>
         <p:spPr>
           <a:xfrm>
-            <a:off x="804672" y="4736592"/>
-            <a:ext cx="365760" cy="365760"/>
+            <a:off x="804672" y="4297680"/>
+            <a:ext cx="347472" cy="347472"/>
           </a:xfrm>
           <a:prstGeom prst="ellipse">
             <a:avLst/>
@@ -20523,8 +20523,8 @@
         </p:nvSpPr>
         <p:spPr>
           <a:xfrm>
-            <a:off x="804672" y="4736592"/>
-            <a:ext cx="365760" cy="365760"/>
+            <a:off x="804672" y="4297680"/>
+            <a:ext cx="347472" cy="347472"/>
           </a:xfrm>
           <a:prstGeom prst="rect">
             <a:avLst/>
@@ -20540,7 +20540,7 @@
               <a:buNone/>
             </a:pPr>
             <a:r>
-              <a:rPr lang="en-US" sz="1200" b="1" dirty="0">
+              <a:rPr lang="en-US" sz="1150" b="1" dirty="0">
                 <a:solidFill>
                   <a:srgbClr val="FFFFFF"/>
                 </a:solidFill>
@@ -20550,7 +20550,7 @@
               </a:rPr>
               <a:t>3</a:t>
             </a:r>
-            <a:endParaRPr lang="en-US" sz="1200" dirty="0"/>
+            <a:endParaRPr lang="en-US" sz="1150" dirty="0"/>
           </a:p>
         </p:txBody>
       </p:sp>
@@ -20562,8 +20562,8 @@
         </p:nvSpPr>
         <p:spPr>
           <a:xfrm>
-            <a:off x="1298448" y="4663440"/>
-            <a:ext cx="2651760" cy="274320"/>
+            <a:off x="1280160" y="4233672"/>
+            <a:ext cx="2651760" cy="256032"/>
           </a:xfrm>
           <a:prstGeom prst="rect">
             <a:avLst/>
@@ -20579,7 +20579,7 @@
               <a:buNone/>
             </a:pPr>
             <a:r>
-              <a:rPr lang="en-US" sz="1350" b="1" dirty="0">
+              <a:rPr lang="en-US" sz="1250" b="1" dirty="0">
                 <a:solidFill>
                   <a:srgbClr val="16232E"/>
                 </a:solidFill>
@@ -20589,7 +20589,7 @@
               </a:rPr>
               <a:t>How relief is shown</a:t>
             </a:r>
-            <a:endParaRPr lang="en-US" sz="1350" dirty="0"/>
+            <a:endParaRPr lang="en-US" sz="1250" dirty="0"/>
           </a:p>
         </p:txBody>
       </p:sp>
@@ -20601,8 +20601,50 @@
         </p:nvSpPr>
         <p:spPr>
           <a:xfrm>
-            <a:off x="1298448" y="4956048"/>
-            <a:ext cx="2651760" cy="713232"/>
+            <a:off x="1280160" y="4498848"/>
+            <a:ext cx="2651760" cy="640080"/>
+          </a:xfrm>
+          <a:prstGeom prst="rect">
+            <a:avLst/>
+          </a:prstGeom>
+          <a:noFill/>
+          <a:ln/>
+        </p:spPr>
+        <p:txBody>
+          <a:bodyPr wrap="square" lIns="0" tIns="0" rIns="0" bIns="0" rtlCol="0" anchor="ctr"/>
+          <a:lstStyle/>
+          <a:p>
+            <a:pPr indent="0" marL="0">
+              <a:lnSpc>
+                <a:spcPts val="1200"/>
+              </a:lnSpc>
+              <a:buNone/>
+            </a:pPr>
+            <a:r>
+              <a:rPr lang="en-US" sz="950" dirty="0">
+                <a:solidFill>
+                  <a:srgbClr val="5D6E7C"/>
+                </a:solidFill>
+                <a:latin typeface="Calibri" pitchFamily="34" charset="0"/>
+                <a:ea typeface="Calibri" pitchFamily="34" charset="-122"/>
+                <a:cs typeface="Calibri" pitchFamily="34" charset="-120"/>
+              </a:rPr>
+              <a:t>Gross PAYE and personal relief each differ by about KES 2,400 — but PAYE payable agrees to four cents.</a:t>
+            </a:r>
+            <a:endParaRPr lang="en-US" sz="950" dirty="0"/>
+          </a:p>
+        </p:txBody>
+      </p:sp>
+      <p:sp>
+        <p:nvSpPr>
+          <p:cNvPr id="24" name="Text 22"/>
+          <p:cNvSpPr txBox="1"/>
+          <p:nvPr/>
+        </p:nvSpPr>
+        <p:spPr>
+          <a:xfrm>
+            <a:off x="4114800" y="4261104"/>
+            <a:ext cx="4572000" cy="859536"/>
           </a:xfrm>
           <a:prstGeom prst="rect">
             <a:avLst/>
@@ -20629,7 +20671,7 @@
                 <a:ea typeface="Calibri" pitchFamily="34" charset="-122"/>
                 <a:cs typeface="Calibri" pitchFamily="34" charset="-120"/>
               </a:rPr>
-              <a:t>Gross PAYE and personal relief each differ by about KES 2,400 — but PAYE payable agrees to four cents.</a:t>
+              <a:t>Where relief exceeds the tax due, we stop at zero rather than carrying a negative. The amount remitted is identical.</a:t>
             </a:r>
             <a:endParaRPr lang="en-US" sz="1000" dirty="0"/>
           </a:p>
@@ -20637,14 +20679,14 @@
       </p:sp>
       <p:sp>
         <p:nvSpPr>
-          <p:cNvPr id="24" name="Text 22"/>
+          <p:cNvPr id="25" name="Text 23"/>
           <p:cNvSpPr txBox="1"/>
           <p:nvPr/>
         </p:nvSpPr>
         <p:spPr>
           <a:xfrm>
-            <a:off x="4133088" y="4681728"/>
-            <a:ext cx="4572000" cy="969264"/>
+            <a:off x="8887968" y="4261104"/>
+            <a:ext cx="2468880" cy="859536"/>
           </a:xfrm>
           <a:prstGeom prst="rect">
             <a:avLst/>
@@ -20658,54 +20700,12 @@
           <a:p>
             <a:pPr indent="0" marL="0">
               <a:lnSpc>
-                <a:spcPts val="1400"/>
+                <a:spcPts val="1250"/>
               </a:lnSpc>
               <a:buNone/>
             </a:pPr>
             <a:r>
-              <a:rPr lang="en-US" sz="1050" dirty="0">
-                <a:solidFill>
-                  <a:srgbClr val="5D6E7C"/>
-                </a:solidFill>
-                <a:latin typeface="Calibri" pitchFamily="34" charset="0"/>
-                <a:ea typeface="Calibri" pitchFamily="34" charset="-122"/>
-                <a:cs typeface="Calibri" pitchFamily="34" charset="-120"/>
-              </a:rPr>
-              <a:t>Where relief exceeds the tax due, we stop at zero rather than carrying a negative. The amount remitted is identical.</a:t>
-            </a:r>
-            <a:endParaRPr lang="en-US" sz="1050" dirty="0"/>
-          </a:p>
-        </p:txBody>
-      </p:sp>
-      <p:sp>
-        <p:nvSpPr>
-          <p:cNvPr id="25" name="Text 23"/>
-          <p:cNvSpPr txBox="1"/>
-          <p:nvPr/>
-        </p:nvSpPr>
-        <p:spPr>
-          <a:xfrm>
-            <a:off x="8887968" y="4681728"/>
-            <a:ext cx="2468880" cy="969264"/>
-          </a:xfrm>
-          <a:prstGeom prst="rect">
-            <a:avLst/>
-          </a:prstGeom>
-          <a:noFill/>
-          <a:ln/>
-        </p:spPr>
-        <p:txBody>
-          <a:bodyPr wrap="square" lIns="0" tIns="0" rIns="0" bIns="0" rtlCol="0" anchor="ctr"/>
-          <a:lstStyle/>
-          <a:p>
-            <a:pPr indent="0" marL="0">
-              <a:lnSpc>
-                <a:spcPts val="1350"/>
-              </a:lnSpc>
-              <a:buNone/>
-            </a:pPr>
-            <a:r>
-              <a:rPr lang="en-US" sz="1000" b="1" dirty="0">
+              <a:rPr lang="en-US" sz="950" b="1" dirty="0">
                 <a:solidFill>
                   <a:srgbClr val="16232E"/>
                 </a:solidFill>
@@ -20717,7 +20717,216 @@
             </a:r>
             <a:pPr indent="0" marL="0">
               <a:lnSpc>
-                <a:spcPts val="1350"/>
+                <a:spcPts val="1250"/>
+              </a:lnSpc>
+              <a:buNone/>
+            </a:pPr>
+            <a:r>
+              <a:rPr lang="en-US" sz="950" dirty="0">
+                <a:solidFill>
+                  <a:srgbClr val="5D6E7C"/>
+                </a:solidFill>
+                <a:latin typeface="Calibri" pitchFamily="34" charset="0"/>
+                <a:ea typeface="Calibri" pitchFamily="34" charset="-122"/>
+                <a:cs typeface="Calibri" pitchFamily="34" charset="-120"/>
+              </a:rPr>
+              <a:t>Happy with how this reads on the payslip?</a:t>
+            </a:r>
+            <a:endParaRPr lang="en-US" sz="950" dirty="0"/>
+          </a:p>
+        </p:txBody>
+      </p:sp>
+      <p:sp>
+        <p:nvSpPr>
+          <p:cNvPr id="26" name="Shape 24"/>
+          <p:cNvSpPr/>
+          <p:nvPr/>
+        </p:nvSpPr>
+        <p:spPr>
+          <a:xfrm>
+            <a:off x="566928" y="5303520"/>
+            <a:ext cx="11055096" cy="1078992"/>
+          </a:xfrm>
+          <a:prstGeom prst="roundRect">
+            <a:avLst>
+              <a:gd name="adj" fmla="val 6780"/>
+            </a:avLst>
+          </a:prstGeom>
+          <a:solidFill>
+            <a:srgbClr val="F4F8FC"/>
+          </a:solidFill>
+          <a:ln w="12700">
+            <a:solidFill>
+              <a:srgbClr val="F4F8FC"/>
+            </a:solidFill>
+            <a:prstDash val="solid"/>
+          </a:ln>
+        </p:spPr>
+      </p:sp>
+      <p:sp>
+        <p:nvSpPr>
+          <p:cNvPr id="27" name="Shape 25"/>
+          <p:cNvSpPr/>
+          <p:nvPr/>
+        </p:nvSpPr>
+        <p:spPr>
+          <a:xfrm>
+            <a:off x="804672" y="5486400"/>
+            <a:ext cx="347472" cy="347472"/>
+          </a:xfrm>
+          <a:prstGeom prst="ellipse">
+            <a:avLst/>
+          </a:prstGeom>
+          <a:solidFill>
+            <a:srgbClr val="0E76BC"/>
+          </a:solidFill>
+          <a:ln/>
+        </p:spPr>
+      </p:sp>
+      <p:sp>
+        <p:nvSpPr>
+          <p:cNvPr id="28" name="Text 26"/>
+          <p:cNvSpPr txBox="1"/>
+          <p:nvPr/>
+        </p:nvSpPr>
+        <p:spPr>
+          <a:xfrm>
+            <a:off x="804672" y="5486400"/>
+            <a:ext cx="347472" cy="347472"/>
+          </a:xfrm>
+          <a:prstGeom prst="rect">
+            <a:avLst/>
+          </a:prstGeom>
+          <a:noFill/>
+          <a:ln/>
+        </p:spPr>
+        <p:txBody>
+          <a:bodyPr wrap="square" lIns="0" tIns="0" rIns="0" bIns="0" rtlCol="0" anchor="ctr"/>
+          <a:lstStyle/>
+          <a:p>
+            <a:pPr algn="ctr" indent="0" marL="0">
+              <a:buNone/>
+            </a:pPr>
+            <a:r>
+              <a:rPr lang="en-US" sz="1150" b="1" dirty="0">
+                <a:solidFill>
+                  <a:srgbClr val="FFFFFF"/>
+                </a:solidFill>
+                <a:latin typeface="Calibri" pitchFamily="34" charset="0"/>
+                <a:ea typeface="Calibri" pitchFamily="34" charset="-122"/>
+                <a:cs typeface="Calibri" pitchFamily="34" charset="-120"/>
+              </a:rPr>
+              <a:t>4</a:t>
+            </a:r>
+            <a:endParaRPr lang="en-US" sz="1150" dirty="0"/>
+          </a:p>
+        </p:txBody>
+      </p:sp>
+      <p:sp>
+        <p:nvSpPr>
+          <p:cNvPr id="29" name="Text 27"/>
+          <p:cNvSpPr txBox="1"/>
+          <p:nvPr/>
+        </p:nvSpPr>
+        <p:spPr>
+          <a:xfrm>
+            <a:off x="1280160" y="5422392"/>
+            <a:ext cx="2651760" cy="256032"/>
+          </a:xfrm>
+          <a:prstGeom prst="rect">
+            <a:avLst/>
+          </a:prstGeom>
+          <a:noFill/>
+          <a:ln/>
+        </p:spPr>
+        <p:txBody>
+          <a:bodyPr wrap="square" lIns="0" tIns="0" rIns="0" bIns="0" rtlCol="0" anchor="ctr"/>
+          <a:lstStyle/>
+          <a:p>
+            <a:pPr indent="0" marL="0">
+              <a:buNone/>
+            </a:pPr>
+            <a:r>
+              <a:rPr lang="en-US" sz="1250" b="1" dirty="0">
+                <a:solidFill>
+                  <a:srgbClr val="16232E"/>
+                </a:solidFill>
+                <a:latin typeface="Calibri" pitchFamily="34" charset="0"/>
+                <a:ea typeface="Calibri" pitchFamily="34" charset="-122"/>
+                <a:cs typeface="Calibri" pitchFamily="34" charset="-120"/>
+              </a:rPr>
+              <a:t>Two duplicate references</a:t>
+            </a:r>
+            <a:endParaRPr lang="en-US" sz="1250" dirty="0"/>
+          </a:p>
+        </p:txBody>
+      </p:sp>
+      <p:sp>
+        <p:nvSpPr>
+          <p:cNvPr id="30" name="Text 28"/>
+          <p:cNvSpPr txBox="1"/>
+          <p:nvPr/>
+        </p:nvSpPr>
+        <p:spPr>
+          <a:xfrm>
+            <a:off x="1280160" y="5687568"/>
+            <a:ext cx="2651760" cy="640080"/>
+          </a:xfrm>
+          <a:prstGeom prst="rect">
+            <a:avLst/>
+          </a:prstGeom>
+          <a:noFill/>
+          <a:ln/>
+        </p:spPr>
+        <p:txBody>
+          <a:bodyPr wrap="square" lIns="0" tIns="0" rIns="0" bIns="0" rtlCol="0" anchor="ctr"/>
+          <a:lstStyle/>
+          <a:p>
+            <a:pPr indent="0" marL="0">
+              <a:lnSpc>
+                <a:spcPts val="1200"/>
+              </a:lnSpc>
+              <a:buNone/>
+            </a:pPr>
+            <a:r>
+              <a:rPr lang="en-US" sz="950" dirty="0">
+                <a:solidFill>
+                  <a:srgbClr val="5D6E7C"/>
+                </a:solidFill>
+                <a:latin typeface="Calibri" pitchFamily="34" charset="0"/>
+                <a:ea typeface="Calibri" pitchFamily="34" charset="-122"/>
+                <a:cs typeface="Calibri" pitchFamily="34" charset="-120"/>
+              </a:rPr>
+              <a:t>Your bank file gives staff 1011 and 1012 the same reference, EMP011 — and 1029 and 1031 both EMP032.</a:t>
+            </a:r>
+            <a:endParaRPr lang="en-US" sz="950" dirty="0"/>
+          </a:p>
+        </p:txBody>
+      </p:sp>
+      <p:sp>
+        <p:nvSpPr>
+          <p:cNvPr id="31" name="Text 29"/>
+          <p:cNvSpPr txBox="1"/>
+          <p:nvPr/>
+        </p:nvSpPr>
+        <p:spPr>
+          <a:xfrm>
+            <a:off x="4114800" y="5449824"/>
+            <a:ext cx="4572000" cy="859536"/>
+          </a:xfrm>
+          <a:prstGeom prst="rect">
+            <a:avLst/>
+          </a:prstGeom>
+          <a:noFill/>
+          <a:ln/>
+        </p:spPr>
+        <p:txBody>
+          <a:bodyPr wrap="square" lIns="0" tIns="0" rIns="0" bIns="0" rtlCol="0" anchor="ctr"/>
+          <a:lstStyle/>
+          <a:p>
+            <a:pPr indent="0" marL="0">
+              <a:lnSpc>
+                <a:spcPts val="1300"/>
               </a:lnSpc>
               <a:buNone/>
             </a:pPr>
@@ -20730,9 +20939,68 @@
                 <a:ea typeface="Calibri" pitchFamily="34" charset="-122"/>
                 <a:cs typeface="Calibri" pitchFamily="34" charset="-120"/>
               </a:rPr>
-              <a:t>Happy with how this reads on the payslip?</a:t>
+              <a:t>Two people sharing a payment reference is the kind of thing a bank queries, or worse, applies to the wrong account.</a:t>
             </a:r>
             <a:endParaRPr lang="en-US" sz="1000" dirty="0"/>
+          </a:p>
+        </p:txBody>
+      </p:sp>
+      <p:sp>
+        <p:nvSpPr>
+          <p:cNvPr id="32" name="Text 30"/>
+          <p:cNvSpPr txBox="1"/>
+          <p:nvPr/>
+        </p:nvSpPr>
+        <p:spPr>
+          <a:xfrm>
+            <a:off x="8887968" y="5449824"/>
+            <a:ext cx="2468880" cy="859536"/>
+          </a:xfrm>
+          <a:prstGeom prst="rect">
+            <a:avLst/>
+          </a:prstGeom>
+          <a:noFill/>
+          <a:ln/>
+        </p:spPr>
+        <p:txBody>
+          <a:bodyPr wrap="square" lIns="0" tIns="0" rIns="0" bIns="0" rtlCol="0" anchor="ctr"/>
+          <a:lstStyle/>
+          <a:p>
+            <a:pPr indent="0" marL="0">
+              <a:lnSpc>
+                <a:spcPts val="1250"/>
+              </a:lnSpc>
+              <a:buNone/>
+            </a:pPr>
+            <a:r>
+              <a:rPr lang="en-US" sz="950" b="1" dirty="0">
+                <a:solidFill>
+                  <a:srgbClr val="16232E"/>
+                </a:solidFill>
+                <a:latin typeface="Calibri" pitchFamily="34" charset="0"/>
+                <a:ea typeface="Calibri" pitchFamily="34" charset="-122"/>
+                <a:cs typeface="Calibri" pitchFamily="34" charset="-120"/>
+              </a:rPr>
+              <a:t>We need:  </a:t>
+            </a:r>
+            <a:pPr indent="0" marL="0">
+              <a:lnSpc>
+                <a:spcPts val="1250"/>
+              </a:lnSpc>
+              <a:buNone/>
+            </a:pPr>
+            <a:r>
+              <a:rPr lang="en-US" sz="950" dirty="0">
+                <a:solidFill>
+                  <a:srgbClr val="5D6E7C"/>
+                </a:solidFill>
+                <a:latin typeface="Calibri" pitchFamily="34" charset="0"/>
+                <a:ea typeface="Calibri" pitchFamily="34" charset="-122"/>
+                <a:cs typeface="Calibri" pitchFamily="34" charset="-120"/>
+              </a:rPr>
+              <a:t>Which reference belongs to whom?</a:t>
+            </a:r>
+            <a:endParaRPr lang="en-US" sz="950" dirty="0"/>
           </a:p>
         </p:txBody>
       </p:sp>

</xml_diff>